<commit_message>
Fix deck text alignment and fit in PowerPoint
Anchor every text box to the top instead of the centre and give table
rows more height so content sits where it is laid out.

Co-Authored-By: Claude Fable 5.1 <noreply@anthropic.com>
Claude-Session: https://claude.ai/code/session_016WzppES3DgkoGxcbTbSKNo
</commit_message>
<xml_diff>
--- a/presentations/mia-corporate-fashion-ip/Mia-at-Work-Corporate-Fashion-IP.pptx
+++ b/presentations/mia-corporate-fashion-ip/Mia-at-Work-Corporate-Fashion-IP.pptx
@@ -2873,7 +2873,7 @@
           <a:ln/>
         </p:spPr>
         <p:txBody>
-          <a:bodyPr wrap="square" lIns="0" tIns="0" rIns="0" bIns="0" rtlCol="0" anchor="ctr"/>
+          <a:bodyPr wrap="square" lIns="0" tIns="0" rIns="0" bIns="0" rtlCol="0" anchor="t"/>
           <a:lstStyle/>
           <a:p>
             <a:pPr indent="0" marL="0">
@@ -2912,7 +2912,7 @@
           <a:ln/>
         </p:spPr>
         <p:txBody>
-          <a:bodyPr wrap="square" lIns="0" tIns="0" rIns="0" bIns="0" rtlCol="0" anchor="ctr"/>
+          <a:bodyPr wrap="square" lIns="0" tIns="0" rIns="0" bIns="0" rtlCol="0" anchor="t"/>
           <a:lstStyle/>
           <a:p>
             <a:pPr indent="0" marL="0">
@@ -2951,7 +2951,7 @@
           <a:ln/>
         </p:spPr>
         <p:txBody>
-          <a:bodyPr wrap="square" lIns="0" tIns="0" rIns="0" bIns="0" rtlCol="0" anchor="ctr"/>
+          <a:bodyPr wrap="square" lIns="0" tIns="0" rIns="0" bIns="0" rtlCol="0" anchor="t"/>
           <a:lstStyle/>
           <a:p>
             <a:pPr indent="0" marL="0">
@@ -2990,7 +2990,7 @@
           <a:ln/>
         </p:spPr>
         <p:txBody>
-          <a:bodyPr wrap="square" lIns="0" tIns="0" rIns="0" bIns="0" rtlCol="0" anchor="ctr"/>
+          <a:bodyPr wrap="square" lIns="0" tIns="0" rIns="0" bIns="0" rtlCol="0" anchor="t"/>
           <a:lstStyle/>
           <a:p>
             <a:pPr indent="0" marL="0">
@@ -3029,7 +3029,7 @@
           <a:ln/>
         </p:spPr>
         <p:txBody>
-          <a:bodyPr wrap="square" lIns="0" tIns="0" rIns="0" bIns="0" rtlCol="0" anchor="ctr"/>
+          <a:bodyPr wrap="square" lIns="0" tIns="0" rIns="0" bIns="0" rtlCol="0" anchor="t"/>
           <a:lstStyle/>
           <a:p>
             <a:pPr indent="0" marL="0">
@@ -3100,7 +3100,7 @@
           <a:ln/>
         </p:spPr>
         <p:txBody>
-          <a:bodyPr wrap="square" lIns="0" tIns="0" rIns="0" bIns="0" rtlCol="0" anchor="ctr"/>
+          <a:bodyPr wrap="square" lIns="0" tIns="0" rIns="0" bIns="0" rtlCol="0" anchor="t"/>
           <a:lstStyle/>
           <a:p>
             <a:pPr indent="0" marL="0">
@@ -3178,7 +3178,7 @@
           <a:ln/>
         </p:spPr>
         <p:txBody>
-          <a:bodyPr wrap="square" lIns="0" tIns="0" rIns="0" bIns="0" rtlCol="0" anchor="ctr"/>
+          <a:bodyPr wrap="square" lIns="0" tIns="0" rIns="0" bIns="0" rtlCol="0" anchor="t"/>
           <a:lstStyle/>
           <a:p>
             <a:pPr indent="0" marL="0">
@@ -3217,7 +3217,7 @@
           <a:ln/>
         </p:spPr>
         <p:txBody>
-          <a:bodyPr wrap="square" lIns="0" tIns="0" rIns="0" bIns="0" rtlCol="0" anchor="ctr"/>
+          <a:bodyPr wrap="square" lIns="0" tIns="0" rIns="0" bIns="0" rtlCol="0" anchor="t"/>
           <a:lstStyle/>
           <a:p>
             <a:pPr algn="r" indent="0" marL="0">
@@ -3283,7 +3283,7 @@
           <a:ln/>
         </p:spPr>
         <p:txBody>
-          <a:bodyPr wrap="square" lIns="0" tIns="0" rIns="0" bIns="0" rtlCol="0" anchor="ctr"/>
+          <a:bodyPr wrap="square" lIns="0" tIns="0" rIns="0" bIns="0" rtlCol="0" anchor="t"/>
           <a:lstStyle/>
           <a:p>
             <a:pPr indent="0" marL="0">
@@ -3322,7 +3322,7 @@
           <a:ln/>
         </p:spPr>
         <p:txBody>
-          <a:bodyPr wrap="square" lIns="0" tIns="0" rIns="0" bIns="0" rtlCol="0" anchor="ctr"/>
+          <a:bodyPr wrap="square" lIns="0" tIns="0" rIns="0" bIns="0" rtlCol="0" anchor="t"/>
           <a:lstStyle/>
           <a:p>
             <a:pPr indent="0" marL="0">
@@ -3427,7 +3427,7 @@
           <a:ln/>
         </p:spPr>
         <p:txBody>
-          <a:bodyPr wrap="square" lIns="0" tIns="0" rIns="0" bIns="0" rtlCol="0" anchor="ctr"/>
+          <a:bodyPr wrap="square" lIns="0" tIns="0" rIns="0" bIns="0" rtlCol="0" anchor="t"/>
           <a:lstStyle/>
           <a:p>
             <a:pPr indent="0" marL="0">
@@ -3466,7 +3466,7 @@
           <a:ln/>
         </p:spPr>
         <p:txBody>
-          <a:bodyPr wrap="square" lIns="0" tIns="0" rIns="0" bIns="0" rtlCol="0" anchor="ctr"/>
+          <a:bodyPr wrap="square" lIns="0" tIns="0" rIns="0" bIns="0" rtlCol="0" anchor="t"/>
           <a:lstStyle/>
           <a:p>
             <a:pPr indent="0" marL="0">
@@ -3571,7 +3571,7 @@
           <a:ln/>
         </p:spPr>
         <p:txBody>
-          <a:bodyPr wrap="square" lIns="0" tIns="0" rIns="0" bIns="0" rtlCol="0" anchor="ctr"/>
+          <a:bodyPr wrap="square" lIns="0" tIns="0" rIns="0" bIns="0" rtlCol="0" anchor="t"/>
           <a:lstStyle/>
           <a:p>
             <a:pPr indent="0" marL="0">
@@ -3610,7 +3610,7 @@
           <a:ln/>
         </p:spPr>
         <p:txBody>
-          <a:bodyPr wrap="square" lIns="0" tIns="0" rIns="0" bIns="0" rtlCol="0" anchor="ctr"/>
+          <a:bodyPr wrap="square" lIns="0" tIns="0" rIns="0" bIns="0" rtlCol="0" anchor="t"/>
           <a:lstStyle/>
           <a:p>
             <a:pPr indent="0" marL="0">
@@ -3688,7 +3688,7 @@
           <a:ln/>
         </p:spPr>
         <p:txBody>
-          <a:bodyPr wrap="square" lIns="0" tIns="0" rIns="0" bIns="0" rtlCol="0" anchor="ctr"/>
+          <a:bodyPr wrap="square" lIns="0" tIns="0" rIns="0" bIns="0" rtlCol="0" anchor="t"/>
           <a:lstStyle/>
           <a:p>
             <a:pPr indent="0" marL="0">
@@ -3759,7 +3759,7 @@
           <a:ln/>
         </p:spPr>
         <p:txBody>
-          <a:bodyPr wrap="square" lIns="0" tIns="0" rIns="0" bIns="0" rtlCol="0" anchor="ctr"/>
+          <a:bodyPr wrap="square" lIns="0" tIns="0" rIns="0" bIns="0" rtlCol="0" anchor="t"/>
           <a:lstStyle/>
           <a:p>
             <a:pPr indent="0" marL="0">
@@ -3837,7 +3837,7 @@
           <a:ln/>
         </p:spPr>
         <p:txBody>
-          <a:bodyPr wrap="square" lIns="0" tIns="0" rIns="0" bIns="0" rtlCol="0" anchor="ctr"/>
+          <a:bodyPr wrap="square" lIns="0" tIns="0" rIns="0" bIns="0" rtlCol="0" anchor="t"/>
           <a:lstStyle/>
           <a:p>
             <a:pPr indent="0" marL="0">
@@ -3876,7 +3876,7 @@
           <a:ln/>
         </p:spPr>
         <p:txBody>
-          <a:bodyPr wrap="square" lIns="0" tIns="0" rIns="0" bIns="0" rtlCol="0" anchor="ctr"/>
+          <a:bodyPr wrap="square" lIns="0" tIns="0" rIns="0" bIns="0" rtlCol="0" anchor="t"/>
           <a:lstStyle/>
           <a:p>
             <a:pPr algn="r" indent="0" marL="0">
@@ -3979,7 +3979,7 @@
           <a:ln/>
         </p:spPr>
         <p:txBody>
-          <a:bodyPr wrap="square" lIns="0" tIns="0" rIns="0" bIns="0" rtlCol="0" anchor="ctr"/>
+          <a:bodyPr wrap="square" lIns="0" tIns="0" rIns="0" bIns="0" rtlCol="0" anchor="t"/>
           <a:lstStyle/>
           <a:p>
             <a:pPr algn="ctr" indent="0" marL="0">
@@ -4018,7 +4018,7 @@
           <a:ln/>
         </p:spPr>
         <p:txBody>
-          <a:bodyPr wrap="square" lIns="0" tIns="0" rIns="0" bIns="0" rtlCol="0" anchor="ctr"/>
+          <a:bodyPr wrap="square" lIns="0" tIns="0" rIns="0" bIns="0" rtlCol="0" anchor="t"/>
           <a:lstStyle/>
           <a:p>
             <a:pPr algn="ctr" indent="0" marL="0">
@@ -4206,7 +4206,7 @@
           <a:ln/>
         </p:spPr>
         <p:txBody>
-          <a:bodyPr wrap="square" lIns="0" tIns="0" rIns="0" bIns="0" rtlCol="0" anchor="ctr"/>
+          <a:bodyPr wrap="square" lIns="0" tIns="0" rIns="0" bIns="0" rtlCol="0" anchor="t"/>
           <a:lstStyle/>
           <a:p>
             <a:pPr algn="ctr" indent="0" marL="0">
@@ -4245,7 +4245,7 @@
           <a:ln/>
         </p:spPr>
         <p:txBody>
-          <a:bodyPr wrap="square" lIns="0" tIns="0" rIns="0" bIns="0" rtlCol="0" anchor="ctr"/>
+          <a:bodyPr wrap="square" lIns="0" tIns="0" rIns="0" bIns="0" rtlCol="0" anchor="t"/>
           <a:lstStyle/>
           <a:p>
             <a:pPr algn="ctr" indent="0" marL="0">
@@ -4433,7 +4433,7 @@
           <a:ln/>
         </p:spPr>
         <p:txBody>
-          <a:bodyPr wrap="square" lIns="0" tIns="0" rIns="0" bIns="0" rtlCol="0" anchor="ctr"/>
+          <a:bodyPr wrap="square" lIns="0" tIns="0" rIns="0" bIns="0" rtlCol="0" anchor="t"/>
           <a:lstStyle/>
           <a:p>
             <a:pPr algn="ctr" indent="0" marL="0">
@@ -4472,7 +4472,7 @@
           <a:ln/>
         </p:spPr>
         <p:txBody>
-          <a:bodyPr wrap="square" lIns="0" tIns="0" rIns="0" bIns="0" rtlCol="0" anchor="ctr"/>
+          <a:bodyPr wrap="square" lIns="0" tIns="0" rIns="0" bIns="0" rtlCol="0" anchor="t"/>
           <a:lstStyle/>
           <a:p>
             <a:pPr algn="ctr" indent="0" marL="0">
@@ -4596,7 +4596,7 @@
           <a:ln/>
         </p:spPr>
         <p:txBody>
-          <a:bodyPr wrap="square" lIns="0" tIns="0" rIns="0" bIns="0" rtlCol="0" anchor="ctr"/>
+          <a:bodyPr wrap="square" lIns="0" tIns="0" rIns="0" bIns="0" rtlCol="0" anchor="t"/>
           <a:lstStyle/>
           <a:p>
             <a:pPr indent="0" marL="0">
@@ -4667,7 +4667,7 @@
           <a:ln/>
         </p:spPr>
         <p:txBody>
-          <a:bodyPr wrap="square" lIns="0" tIns="0" rIns="0" bIns="0" rtlCol="0" anchor="ctr"/>
+          <a:bodyPr wrap="square" lIns="0" tIns="0" rIns="0" bIns="0" rtlCol="0" anchor="t"/>
           <a:lstStyle/>
           <a:p>
             <a:pPr indent="0" marL="0">
@@ -4745,7 +4745,7 @@
           <a:ln/>
         </p:spPr>
         <p:txBody>
-          <a:bodyPr wrap="square" lIns="0" tIns="0" rIns="0" bIns="0" rtlCol="0" anchor="ctr"/>
+          <a:bodyPr wrap="square" lIns="0" tIns="0" rIns="0" bIns="0" rtlCol="0" anchor="t"/>
           <a:lstStyle/>
           <a:p>
             <a:pPr indent="0" marL="0">
@@ -4784,7 +4784,7 @@
           <a:ln/>
         </p:spPr>
         <p:txBody>
-          <a:bodyPr wrap="square" lIns="0" tIns="0" rIns="0" bIns="0" rtlCol="0" anchor="ctr"/>
+          <a:bodyPr wrap="square" lIns="0" tIns="0" rIns="0" bIns="0" rtlCol="0" anchor="t"/>
           <a:lstStyle/>
           <a:p>
             <a:pPr algn="r" indent="0" marL="0">
@@ -5955,7 +5955,7 @@
           <a:ln/>
         </p:spPr>
         <p:txBody>
-          <a:bodyPr wrap="square" lIns="0" tIns="0" rIns="0" bIns="0" rtlCol="0" anchor="ctr"/>
+          <a:bodyPr wrap="square" lIns="0" tIns="0" rIns="0" bIns="0" rtlCol="0" anchor="t"/>
           <a:lstStyle/>
           <a:p>
             <a:pPr indent="0" marL="0">
@@ -6026,7 +6026,7 @@
           <a:ln/>
         </p:spPr>
         <p:txBody>
-          <a:bodyPr wrap="square" lIns="0" tIns="0" rIns="0" bIns="0" rtlCol="0" anchor="ctr"/>
+          <a:bodyPr wrap="square" lIns="0" tIns="0" rIns="0" bIns="0" rtlCol="0" anchor="t"/>
           <a:lstStyle/>
           <a:p>
             <a:pPr algn="r" indent="0" marL="0">
@@ -6065,7 +6065,7 @@
           <a:ln/>
         </p:spPr>
         <p:txBody>
-          <a:bodyPr wrap="square" lIns="0" tIns="0" rIns="0" bIns="0" rtlCol="0" anchor="ctr"/>
+          <a:bodyPr wrap="square" lIns="0" tIns="0" rIns="0" bIns="0" rtlCol="0" anchor="t"/>
           <a:lstStyle/>
           <a:p>
             <a:pPr indent="0" marL="0">
@@ -6209,7 +6209,7 @@
           <a:ln/>
         </p:spPr>
         <p:txBody>
-          <a:bodyPr wrap="square" lIns="0" tIns="0" rIns="0" bIns="0" rtlCol="0" anchor="ctr"/>
+          <a:bodyPr wrap="square" lIns="0" tIns="0" rIns="0" bIns="0" rtlCol="0" anchor="t"/>
           <a:lstStyle/>
           <a:p>
             <a:pPr indent="0" marL="0">
@@ -6248,7 +6248,7 @@
           <a:ln/>
         </p:spPr>
         <p:txBody>
-          <a:bodyPr wrap="square" lIns="0" tIns="0" rIns="0" bIns="0" rtlCol="0" anchor="ctr"/>
+          <a:bodyPr wrap="square" lIns="0" tIns="0" rIns="0" bIns="0" rtlCol="0" anchor="t"/>
           <a:lstStyle/>
           <a:p>
             <a:pPr indent="0" marL="0">
@@ -6353,7 +6353,7 @@
           <a:ln/>
         </p:spPr>
         <p:txBody>
-          <a:bodyPr wrap="square" lIns="0" tIns="0" rIns="0" bIns="0" rtlCol="0" anchor="ctr"/>
+          <a:bodyPr wrap="square" lIns="0" tIns="0" rIns="0" bIns="0" rtlCol="0" anchor="t"/>
           <a:lstStyle/>
           <a:p>
             <a:pPr indent="0" marL="0">
@@ -6392,7 +6392,7 @@
           <a:ln/>
         </p:spPr>
         <p:txBody>
-          <a:bodyPr wrap="square" lIns="0" tIns="0" rIns="0" bIns="0" rtlCol="0" anchor="ctr"/>
+          <a:bodyPr wrap="square" lIns="0" tIns="0" rIns="0" bIns="0" rtlCol="0" anchor="t"/>
           <a:lstStyle/>
           <a:p>
             <a:pPr indent="0" marL="0">
@@ -6497,7 +6497,7 @@
           <a:ln/>
         </p:spPr>
         <p:txBody>
-          <a:bodyPr wrap="square" lIns="0" tIns="0" rIns="0" bIns="0" rtlCol="0" anchor="ctr"/>
+          <a:bodyPr wrap="square" lIns="0" tIns="0" rIns="0" bIns="0" rtlCol="0" anchor="t"/>
           <a:lstStyle/>
           <a:p>
             <a:pPr indent="0" marL="0">
@@ -6536,7 +6536,7 @@
           <a:ln/>
         </p:spPr>
         <p:txBody>
-          <a:bodyPr wrap="square" lIns="0" tIns="0" rIns="0" bIns="0" rtlCol="0" anchor="ctr"/>
+          <a:bodyPr wrap="square" lIns="0" tIns="0" rIns="0" bIns="0" rtlCol="0" anchor="t"/>
           <a:lstStyle/>
           <a:p>
             <a:pPr indent="0" marL="0">
@@ -6641,7 +6641,7 @@
           <a:ln/>
         </p:spPr>
         <p:txBody>
-          <a:bodyPr wrap="square" lIns="0" tIns="0" rIns="0" bIns="0" rtlCol="0" anchor="ctr"/>
+          <a:bodyPr wrap="square" lIns="0" tIns="0" rIns="0" bIns="0" rtlCol="0" anchor="t"/>
           <a:lstStyle/>
           <a:p>
             <a:pPr indent="0" marL="0">
@@ -6680,7 +6680,7 @@
           <a:ln/>
         </p:spPr>
         <p:txBody>
-          <a:bodyPr wrap="square" lIns="0" tIns="0" rIns="0" bIns="0" rtlCol="0" anchor="ctr"/>
+          <a:bodyPr wrap="square" lIns="0" tIns="0" rIns="0" bIns="0" rtlCol="0" anchor="t"/>
           <a:lstStyle/>
           <a:p>
             <a:pPr indent="0" marL="0">
@@ -6785,7 +6785,7 @@
           <a:ln/>
         </p:spPr>
         <p:txBody>
-          <a:bodyPr wrap="square" lIns="0" tIns="0" rIns="0" bIns="0" rtlCol="0" anchor="ctr"/>
+          <a:bodyPr wrap="square" lIns="0" tIns="0" rIns="0" bIns="0" rtlCol="0" anchor="t"/>
           <a:lstStyle/>
           <a:p>
             <a:pPr indent="0" marL="0">
@@ -6824,7 +6824,7 @@
           <a:ln/>
         </p:spPr>
         <p:txBody>
-          <a:bodyPr wrap="square" lIns="0" tIns="0" rIns="0" bIns="0" rtlCol="0" anchor="ctr"/>
+          <a:bodyPr wrap="square" lIns="0" tIns="0" rIns="0" bIns="0" rtlCol="0" anchor="t"/>
           <a:lstStyle/>
           <a:p>
             <a:pPr indent="0" marL="0">
@@ -6929,7 +6929,7 @@
           <a:ln/>
         </p:spPr>
         <p:txBody>
-          <a:bodyPr wrap="square" lIns="0" tIns="0" rIns="0" bIns="0" rtlCol="0" anchor="ctr"/>
+          <a:bodyPr wrap="square" lIns="0" tIns="0" rIns="0" bIns="0" rtlCol="0" anchor="t"/>
           <a:lstStyle/>
           <a:p>
             <a:pPr indent="0" marL="0">
@@ -6968,7 +6968,7 @@
           <a:ln/>
         </p:spPr>
         <p:txBody>
-          <a:bodyPr wrap="square" lIns="0" tIns="0" rIns="0" bIns="0" rtlCol="0" anchor="ctr"/>
+          <a:bodyPr wrap="square" lIns="0" tIns="0" rIns="0" bIns="0" rtlCol="0" anchor="t"/>
           <a:lstStyle/>
           <a:p>
             <a:pPr indent="0" marL="0">
@@ -7073,7 +7073,7 @@
           <a:ln/>
         </p:spPr>
         <p:txBody>
-          <a:bodyPr wrap="square" lIns="0" tIns="0" rIns="0" bIns="0" rtlCol="0" anchor="ctr"/>
+          <a:bodyPr wrap="square" lIns="0" tIns="0" rIns="0" bIns="0" rtlCol="0" anchor="t"/>
           <a:lstStyle/>
           <a:p>
             <a:pPr indent="0" marL="0">
@@ -7112,7 +7112,7 @@
           <a:ln/>
         </p:spPr>
         <p:txBody>
-          <a:bodyPr wrap="square" lIns="0" tIns="0" rIns="0" bIns="0" rtlCol="0" anchor="ctr"/>
+          <a:bodyPr wrap="square" lIns="0" tIns="0" rIns="0" bIns="0" rtlCol="0" anchor="t"/>
           <a:lstStyle/>
           <a:p>
             <a:pPr indent="0" marL="0">
@@ -7217,7 +7217,7 @@
           <a:ln/>
         </p:spPr>
         <p:txBody>
-          <a:bodyPr wrap="square" lIns="0" tIns="0" rIns="0" bIns="0" rtlCol="0" anchor="ctr"/>
+          <a:bodyPr wrap="square" lIns="0" tIns="0" rIns="0" bIns="0" rtlCol="0" anchor="t"/>
           <a:lstStyle/>
           <a:p>
             <a:pPr indent="0" marL="0">
@@ -7256,7 +7256,7 @@
           <a:ln/>
         </p:spPr>
         <p:txBody>
-          <a:bodyPr wrap="square" lIns="0" tIns="0" rIns="0" bIns="0" rtlCol="0" anchor="ctr"/>
+          <a:bodyPr wrap="square" lIns="0" tIns="0" rIns="0" bIns="0" rtlCol="0" anchor="t"/>
           <a:lstStyle/>
           <a:p>
             <a:pPr indent="0" marL="0">
@@ -7295,7 +7295,7 @@
           <a:ln/>
         </p:spPr>
         <p:txBody>
-          <a:bodyPr wrap="square" lIns="0" tIns="0" rIns="0" bIns="0" rtlCol="0" anchor="ctr"/>
+          <a:bodyPr wrap="square" lIns="0" tIns="0" rIns="0" bIns="0" rtlCol="0" anchor="t"/>
           <a:lstStyle/>
           <a:p>
             <a:pPr indent="0" marL="0">
@@ -7366,7 +7366,7 @@
           <a:ln/>
         </p:spPr>
         <p:txBody>
-          <a:bodyPr wrap="square" lIns="0" tIns="0" rIns="0" bIns="0" rtlCol="0" anchor="ctr"/>
+          <a:bodyPr wrap="square" lIns="0" tIns="0" rIns="0" bIns="0" rtlCol="0" anchor="t"/>
           <a:lstStyle/>
           <a:p>
             <a:pPr indent="0" marL="0">
@@ -7444,7 +7444,7 @@
           <a:ln/>
         </p:spPr>
         <p:txBody>
-          <a:bodyPr wrap="square" lIns="0" tIns="0" rIns="0" bIns="0" rtlCol="0" anchor="ctr"/>
+          <a:bodyPr wrap="square" lIns="0" tIns="0" rIns="0" bIns="0" rtlCol="0" anchor="t"/>
           <a:lstStyle/>
           <a:p>
             <a:pPr indent="0" marL="0">
@@ -7483,7 +7483,7 @@
           <a:ln/>
         </p:spPr>
         <p:txBody>
-          <a:bodyPr wrap="square" lIns="0" tIns="0" rIns="0" bIns="0" rtlCol="0" anchor="ctr"/>
+          <a:bodyPr wrap="square" lIns="0" tIns="0" rIns="0" bIns="0" rtlCol="0" anchor="t"/>
           <a:lstStyle/>
           <a:p>
             <a:pPr algn="r" indent="0" marL="0">
@@ -7598,7 +7598,7 @@
           <a:ln/>
         </p:spPr>
         <p:txBody>
-          <a:bodyPr wrap="square" lIns="0" tIns="0" rIns="0" bIns="0" rtlCol="0" anchor="ctr"/>
+          <a:bodyPr wrap="square" lIns="0" tIns="0" rIns="0" bIns="0" rtlCol="0" anchor="t"/>
           <a:lstStyle/>
           <a:p>
             <a:pPr indent="0" marL="0">
@@ -7752,7 +7752,7 @@
           <a:ln/>
         </p:spPr>
         <p:txBody>
-          <a:bodyPr wrap="square" lIns="0" tIns="0" rIns="0" bIns="0" rtlCol="0" anchor="ctr"/>
+          <a:bodyPr wrap="square" lIns="0" tIns="0" rIns="0" bIns="0" rtlCol="0" anchor="t"/>
           <a:lstStyle/>
           <a:p>
             <a:pPr indent="0" marL="0">
@@ -7906,7 +7906,7 @@
           <a:ln/>
         </p:spPr>
         <p:txBody>
-          <a:bodyPr wrap="square" lIns="0" tIns="0" rIns="0" bIns="0" rtlCol="0" anchor="ctr"/>
+          <a:bodyPr wrap="square" lIns="0" tIns="0" rIns="0" bIns="0" rtlCol="0" anchor="t"/>
           <a:lstStyle/>
           <a:p>
             <a:pPr indent="0" marL="0">
@@ -8060,7 +8060,7 @@
           <a:ln/>
         </p:spPr>
         <p:txBody>
-          <a:bodyPr wrap="square" lIns="0" tIns="0" rIns="0" bIns="0" rtlCol="0" anchor="ctr"/>
+          <a:bodyPr wrap="square" lIns="0" tIns="0" rIns="0" bIns="0" rtlCol="0" anchor="t"/>
           <a:lstStyle/>
           <a:p>
             <a:pPr indent="0" marL="0">
@@ -8170,7 +8170,7 @@
           <a:ln/>
         </p:spPr>
         <p:txBody>
-          <a:bodyPr wrap="square" lIns="0" tIns="0" rIns="0" bIns="0" rtlCol="0" anchor="ctr"/>
+          <a:bodyPr wrap="square" lIns="0" tIns="0" rIns="0" bIns="0" rtlCol="0" anchor="t"/>
           <a:lstStyle/>
           <a:p>
             <a:pPr indent="0" marL="0">
@@ -8248,7 +8248,7 @@
           <a:ln/>
         </p:spPr>
         <p:txBody>
-          <a:bodyPr wrap="square" lIns="0" tIns="0" rIns="0" bIns="0" rtlCol="0" anchor="ctr"/>
+          <a:bodyPr wrap="square" lIns="0" tIns="0" rIns="0" bIns="0" rtlCol="0" anchor="t"/>
           <a:lstStyle/>
           <a:p>
             <a:pPr indent="0" marL="0">
@@ -8287,7 +8287,7 @@
           <a:ln/>
         </p:spPr>
         <p:txBody>
-          <a:bodyPr wrap="square" lIns="0" tIns="0" rIns="0" bIns="0" rtlCol="0" anchor="ctr"/>
+          <a:bodyPr wrap="square" lIns="0" tIns="0" rIns="0" bIns="0" rtlCol="0" anchor="t"/>
           <a:lstStyle/>
           <a:p>
             <a:pPr algn="r" indent="0" marL="0">
@@ -8336,7 +8336,7 @@
                 <a:gridCol w="2468880"/>
                 <a:gridCol w="1097280"/>
               </a:tblGrid>
-              <a:tr h="347472">
+              <a:tr h="384048">
                 <a:tc>
                   <a:txBody>
                     <a:bodyPr/>
@@ -8610,7 +8610,7 @@
                   </a:tcPr>
                 </a:tc>
               </a:tr>
-              <a:tr h="347472">
+              <a:tr h="384048">
                 <a:tc>
                   <a:txBody>
                     <a:bodyPr/>
@@ -8884,7 +8884,7 @@
                   </a:tcPr>
                 </a:tc>
               </a:tr>
-              <a:tr h="347472">
+              <a:tr h="384048">
                 <a:tc>
                   <a:txBody>
                     <a:bodyPr/>
@@ -9158,7 +9158,7 @@
                   </a:tcPr>
                 </a:tc>
               </a:tr>
-              <a:tr h="347472">
+              <a:tr h="384048">
                 <a:tc>
                   <a:txBody>
                     <a:bodyPr/>
@@ -9432,7 +9432,7 @@
                   </a:tcPr>
                 </a:tc>
               </a:tr>
-              <a:tr h="347472">
+              <a:tr h="384048">
                 <a:tc>
                   <a:txBody>
                     <a:bodyPr/>
@@ -9706,7 +9706,7 @@
                   </a:tcPr>
                 </a:tc>
               </a:tr>
-              <a:tr h="347472">
+              <a:tr h="384048">
                 <a:tc>
                   <a:txBody>
                     <a:bodyPr/>
@@ -9980,7 +9980,7 @@
                   </a:tcPr>
                 </a:tc>
               </a:tr>
-              <a:tr h="347472">
+              <a:tr h="384048">
                 <a:tc>
                   <a:txBody>
                     <a:bodyPr/>
@@ -10254,7 +10254,7 @@
                   </a:tcPr>
                 </a:tc>
               </a:tr>
-              <a:tr h="347472">
+              <a:tr h="384048">
                 <a:tc>
                   <a:txBody>
                     <a:bodyPr/>
@@ -10582,7 +10582,7 @@
           <a:ln/>
         </p:spPr>
         <p:txBody>
-          <a:bodyPr wrap="square" lIns="0" tIns="0" rIns="0" bIns="0" rtlCol="0" anchor="ctr"/>
+          <a:bodyPr wrap="square" lIns="0" tIns="0" rIns="0" bIns="0" rtlCol="0" anchor="t"/>
           <a:lstStyle/>
           <a:p>
             <a:pPr indent="0" marL="0">
@@ -10660,7 +10660,7 @@
           <a:ln/>
         </p:spPr>
         <p:txBody>
-          <a:bodyPr wrap="square" lIns="0" tIns="0" rIns="0" bIns="0" rtlCol="0" anchor="ctr"/>
+          <a:bodyPr wrap="square" lIns="0" tIns="0" rIns="0" bIns="0" rtlCol="0" anchor="t"/>
           <a:lstStyle/>
           <a:p>
             <a:pPr indent="0" marL="0">
@@ -10699,7 +10699,7 @@
           <a:ln/>
         </p:spPr>
         <p:txBody>
-          <a:bodyPr wrap="square" lIns="0" tIns="0" rIns="0" bIns="0" rtlCol="0" anchor="ctr"/>
+          <a:bodyPr wrap="square" lIns="0" tIns="0" rIns="0" bIns="0" rtlCol="0" anchor="t"/>
           <a:lstStyle/>
           <a:p>
             <a:pPr algn="r" indent="0" marL="0">
@@ -10781,7 +10781,7 @@
           <a:ln/>
         </p:spPr>
         <p:txBody>
-          <a:bodyPr wrap="square" lIns="0" tIns="0" rIns="0" bIns="0" rtlCol="0" anchor="ctr"/>
+          <a:bodyPr wrap="square" lIns="0" tIns="0" rIns="0" bIns="0" rtlCol="0" anchor="t"/>
           <a:lstStyle/>
           <a:p>
             <a:pPr indent="0" marL="0">
@@ -10820,7 +10820,7 @@
           <a:ln/>
         </p:spPr>
         <p:txBody>
-          <a:bodyPr wrap="square" lIns="0" tIns="0" rIns="0" bIns="0" rtlCol="0" anchor="ctr"/>
+          <a:bodyPr wrap="square" lIns="0" tIns="0" rIns="0" bIns="0" rtlCol="0" anchor="t"/>
           <a:lstStyle/>
           <a:p>
             <a:pPr indent="0" marL="0">
@@ -10859,7 +10859,7 @@
           <a:ln/>
         </p:spPr>
         <p:txBody>
-          <a:bodyPr wrap="square" lIns="0" tIns="0" rIns="0" bIns="0" rtlCol="0" anchor="ctr"/>
+          <a:bodyPr wrap="square" lIns="0" tIns="0" rIns="0" bIns="0" rtlCol="0" anchor="t"/>
           <a:lstStyle/>
           <a:p>
             <a:pPr indent="0" marL="0">
@@ -11015,7 +11015,7 @@
           <a:ln/>
         </p:spPr>
         <p:txBody>
-          <a:bodyPr wrap="square" lIns="0" tIns="0" rIns="0" bIns="0" rtlCol="0" anchor="ctr"/>
+          <a:bodyPr wrap="square" lIns="0" tIns="0" rIns="0" bIns="0" rtlCol="0" anchor="t"/>
           <a:lstStyle/>
           <a:p>
             <a:pPr indent="0" marL="0">
@@ -11093,7 +11093,7 @@
           <a:ln/>
         </p:spPr>
         <p:txBody>
-          <a:bodyPr wrap="square" lIns="0" tIns="0" rIns="0" bIns="0" rtlCol="0" anchor="ctr"/>
+          <a:bodyPr wrap="square" lIns="0" tIns="0" rIns="0" bIns="0" rtlCol="0" anchor="t"/>
           <a:lstStyle/>
           <a:p>
             <a:pPr indent="0" marL="0">
@@ -11132,7 +11132,7 @@
           <a:ln/>
         </p:spPr>
         <p:txBody>
-          <a:bodyPr wrap="square" lIns="0" tIns="0" rIns="0" bIns="0" rtlCol="0" anchor="ctr"/>
+          <a:bodyPr wrap="square" lIns="0" tIns="0" rIns="0" bIns="0" rtlCol="0" anchor="t"/>
           <a:lstStyle/>
           <a:p>
             <a:pPr algn="r" indent="0" marL="0">
@@ -11247,7 +11247,7 @@
           <a:ln/>
         </p:spPr>
         <p:txBody>
-          <a:bodyPr wrap="square" lIns="0" tIns="0" rIns="0" bIns="0" rtlCol="0" anchor="ctr"/>
+          <a:bodyPr wrap="square" lIns="0" tIns="0" rIns="0" bIns="0" rtlCol="0" anchor="t"/>
           <a:lstStyle/>
           <a:p>
             <a:pPr indent="0" marL="0">
@@ -11401,7 +11401,7 @@
           <a:ln/>
         </p:spPr>
         <p:txBody>
-          <a:bodyPr wrap="square" lIns="0" tIns="0" rIns="0" bIns="0" rtlCol="0" anchor="ctr"/>
+          <a:bodyPr wrap="square" lIns="0" tIns="0" rIns="0" bIns="0" rtlCol="0" anchor="t"/>
           <a:lstStyle/>
           <a:p>
             <a:pPr indent="0" marL="0">
@@ -11555,7 +11555,7 @@
           <a:ln/>
         </p:spPr>
         <p:txBody>
-          <a:bodyPr wrap="square" lIns="0" tIns="0" rIns="0" bIns="0" rtlCol="0" anchor="ctr"/>
+          <a:bodyPr wrap="square" lIns="0" tIns="0" rIns="0" bIns="0" rtlCol="0" anchor="t"/>
           <a:lstStyle/>
           <a:p>
             <a:pPr indent="0" marL="0">
@@ -11709,7 +11709,7 @@
           <a:ln/>
         </p:spPr>
         <p:txBody>
-          <a:bodyPr wrap="square" lIns="0" tIns="0" rIns="0" bIns="0" rtlCol="0" anchor="ctr"/>
+          <a:bodyPr wrap="square" lIns="0" tIns="0" rIns="0" bIns="0" rtlCol="0" anchor="t"/>
           <a:lstStyle/>
           <a:p>
             <a:pPr indent="0" marL="0">
@@ -11863,7 +11863,7 @@
           <a:ln/>
         </p:spPr>
         <p:txBody>
-          <a:bodyPr wrap="square" lIns="0" tIns="0" rIns="0" bIns="0" rtlCol="0" anchor="ctr"/>
+          <a:bodyPr wrap="square" lIns="0" tIns="0" rIns="0" bIns="0" rtlCol="0" anchor="t"/>
           <a:lstStyle/>
           <a:p>
             <a:pPr indent="0" marL="0">
@@ -12017,7 +12017,7 @@
           <a:ln/>
         </p:spPr>
         <p:txBody>
-          <a:bodyPr wrap="square" lIns="0" tIns="0" rIns="0" bIns="0" rtlCol="0" anchor="ctr"/>
+          <a:bodyPr wrap="square" lIns="0" tIns="0" rIns="0" bIns="0" rtlCol="0" anchor="t"/>
           <a:lstStyle/>
           <a:p>
             <a:pPr indent="0" marL="0">
@@ -12095,7 +12095,7 @@
           <a:ln/>
         </p:spPr>
         <p:txBody>
-          <a:bodyPr wrap="square" lIns="0" tIns="0" rIns="0" bIns="0" rtlCol="0" anchor="ctr"/>
+          <a:bodyPr wrap="square" lIns="0" tIns="0" rIns="0" bIns="0" rtlCol="0" anchor="t"/>
           <a:lstStyle/>
           <a:p>
             <a:pPr indent="0" marL="0">
@@ -12166,7 +12166,7 @@
           <a:ln/>
         </p:spPr>
         <p:txBody>
-          <a:bodyPr wrap="square" lIns="0" tIns="0" rIns="0" bIns="0" rtlCol="0" anchor="ctr"/>
+          <a:bodyPr wrap="square" lIns="0" tIns="0" rIns="0" bIns="0" rtlCol="0" anchor="t"/>
           <a:lstStyle/>
           <a:p>
             <a:pPr indent="0" marL="0">
@@ -12244,7 +12244,7 @@
           <a:ln/>
         </p:spPr>
         <p:txBody>
-          <a:bodyPr wrap="square" lIns="0" tIns="0" rIns="0" bIns="0" rtlCol="0" anchor="ctr"/>
+          <a:bodyPr wrap="square" lIns="0" tIns="0" rIns="0" bIns="0" rtlCol="0" anchor="t"/>
           <a:lstStyle/>
           <a:p>
             <a:pPr indent="0" marL="0">
@@ -12283,7 +12283,7 @@
           <a:ln/>
         </p:spPr>
         <p:txBody>
-          <a:bodyPr wrap="square" lIns="0" tIns="0" rIns="0" bIns="0" rtlCol="0" anchor="ctr"/>
+          <a:bodyPr wrap="square" lIns="0" tIns="0" rIns="0" bIns="0" rtlCol="0" anchor="t"/>
           <a:lstStyle/>
           <a:p>
             <a:pPr algn="r" indent="0" marL="0">
@@ -12349,7 +12349,7 @@
           <a:ln/>
         </p:spPr>
         <p:txBody>
-          <a:bodyPr wrap="square" lIns="0" tIns="0" rIns="0" bIns="0" rtlCol="0" anchor="ctr"/>
+          <a:bodyPr wrap="square" lIns="0" tIns="0" rIns="0" bIns="0" rtlCol="0" anchor="t"/>
           <a:lstStyle/>
           <a:p>
             <a:pPr indent="0" marL="0">
@@ -12542,7 +12542,7 @@
           <a:ln/>
         </p:spPr>
         <p:txBody>
-          <a:bodyPr wrap="square" lIns="0" tIns="0" rIns="0" bIns="0" rtlCol="0" anchor="ctr"/>
+          <a:bodyPr wrap="square" lIns="0" tIns="0" rIns="0" bIns="0" rtlCol="0" anchor="t"/>
           <a:lstStyle/>
           <a:p>
             <a:pPr indent="0" marL="0">
@@ -12740,7 +12740,7 @@
           <a:ln/>
         </p:spPr>
         <p:txBody>
-          <a:bodyPr wrap="square" lIns="0" tIns="0" rIns="0" bIns="0" rtlCol="0" anchor="ctr"/>
+          <a:bodyPr wrap="square" lIns="0" tIns="0" rIns="0" bIns="0" rtlCol="0" anchor="t"/>
           <a:lstStyle/>
           <a:p>
             <a:pPr indent="0" marL="0">
@@ -12818,7 +12818,7 @@
           <a:ln/>
         </p:spPr>
         <p:txBody>
-          <a:bodyPr wrap="square" lIns="0" tIns="0" rIns="0" bIns="0" rtlCol="0" anchor="ctr"/>
+          <a:bodyPr wrap="square" lIns="0" tIns="0" rIns="0" bIns="0" rtlCol="0" anchor="t"/>
           <a:lstStyle/>
           <a:p>
             <a:pPr indent="0" marL="0">
@@ -12857,7 +12857,7 @@
           <a:ln/>
         </p:spPr>
         <p:txBody>
-          <a:bodyPr wrap="square" lIns="0" tIns="0" rIns="0" bIns="0" rtlCol="0" anchor="ctr"/>
+          <a:bodyPr wrap="square" lIns="0" tIns="0" rIns="0" bIns="0" rtlCol="0" anchor="t"/>
           <a:lstStyle/>
           <a:p>
             <a:pPr algn="r" indent="0" marL="0">
@@ -13453,7 +13453,7 @@
           <a:ln/>
         </p:spPr>
         <p:txBody>
-          <a:bodyPr wrap="square" lIns="0" tIns="0" rIns="0" bIns="0" rtlCol="0" anchor="ctr"/>
+          <a:bodyPr wrap="square" lIns="0" tIns="0" rIns="0" bIns="0" rtlCol="0" anchor="t"/>
           <a:lstStyle/>
           <a:p>
             <a:pPr indent="0" marL="0">
@@ -13531,7 +13531,7 @@
           <a:ln/>
         </p:spPr>
         <p:txBody>
-          <a:bodyPr wrap="square" lIns="0" tIns="0" rIns="0" bIns="0" rtlCol="0" anchor="ctr"/>
+          <a:bodyPr wrap="square" lIns="0" tIns="0" rIns="0" bIns="0" rtlCol="0" anchor="t"/>
           <a:lstStyle/>
           <a:p>
             <a:pPr indent="0" marL="0">
@@ -13570,7 +13570,7 @@
           <a:ln/>
         </p:spPr>
         <p:txBody>
-          <a:bodyPr wrap="square" lIns="0" tIns="0" rIns="0" bIns="0" rtlCol="0" anchor="ctr"/>
+          <a:bodyPr wrap="square" lIns="0" tIns="0" rIns="0" bIns="0" rtlCol="0" anchor="t"/>
           <a:lstStyle/>
           <a:p>
             <a:pPr algn="r" indent="0" marL="0">
@@ -13685,7 +13685,7 @@
           <a:ln/>
         </p:spPr>
         <p:txBody>
-          <a:bodyPr wrap="square" lIns="0" tIns="0" rIns="0" bIns="0" rtlCol="0" anchor="ctr"/>
+          <a:bodyPr wrap="square" lIns="0" tIns="0" rIns="0" bIns="0" rtlCol="0" anchor="t"/>
           <a:lstStyle/>
           <a:p>
             <a:pPr indent="0" marL="0">
@@ -13839,7 +13839,7 @@
           <a:ln/>
         </p:spPr>
         <p:txBody>
-          <a:bodyPr wrap="square" lIns="0" tIns="0" rIns="0" bIns="0" rtlCol="0" anchor="ctr"/>
+          <a:bodyPr wrap="square" lIns="0" tIns="0" rIns="0" bIns="0" rtlCol="0" anchor="t"/>
           <a:lstStyle/>
           <a:p>
             <a:pPr indent="0" marL="0">
@@ -13993,7 +13993,7 @@
           <a:ln/>
         </p:spPr>
         <p:txBody>
-          <a:bodyPr wrap="square" lIns="0" tIns="0" rIns="0" bIns="0" rtlCol="0" anchor="ctr"/>
+          <a:bodyPr wrap="square" lIns="0" tIns="0" rIns="0" bIns="0" rtlCol="0" anchor="t"/>
           <a:lstStyle/>
           <a:p>
             <a:pPr indent="0" marL="0">
@@ -14147,7 +14147,7 @@
           <a:ln/>
         </p:spPr>
         <p:txBody>
-          <a:bodyPr wrap="square" lIns="0" tIns="0" rIns="0" bIns="0" rtlCol="0" anchor="ctr"/>
+          <a:bodyPr wrap="square" lIns="0" tIns="0" rIns="0" bIns="0" rtlCol="0" anchor="t"/>
           <a:lstStyle/>
           <a:p>
             <a:pPr indent="0" marL="0">
@@ -14225,7 +14225,7 @@
           <a:ln/>
         </p:spPr>
         <p:txBody>
-          <a:bodyPr wrap="square" lIns="0" tIns="0" rIns="0" bIns="0" rtlCol="0" anchor="ctr"/>
+          <a:bodyPr wrap="square" lIns="0" tIns="0" rIns="0" bIns="0" rtlCol="0" anchor="t"/>
           <a:lstStyle/>
           <a:p>
             <a:pPr indent="0" marL="0">
@@ -14296,7 +14296,7 @@
           <a:ln/>
         </p:spPr>
         <p:txBody>
-          <a:bodyPr wrap="square" lIns="0" tIns="0" rIns="0" bIns="0" rtlCol="0" anchor="ctr"/>
+          <a:bodyPr wrap="square" lIns="0" tIns="0" rIns="0" bIns="0" rtlCol="0" anchor="t"/>
           <a:lstStyle/>
           <a:p>
             <a:pPr algn="r" indent="0" marL="0">
@@ -14335,7 +14335,7 @@
           <a:ln/>
         </p:spPr>
         <p:txBody>
-          <a:bodyPr wrap="square" lIns="0" tIns="0" rIns="0" bIns="0" rtlCol="0" anchor="ctr"/>
+          <a:bodyPr wrap="square" lIns="0" tIns="0" rIns="0" bIns="0" rtlCol="0" anchor="t"/>
           <a:lstStyle/>
           <a:p>
             <a:pPr indent="0" marL="0">
@@ -14374,7 +14374,7 @@
           <a:ln/>
         </p:spPr>
         <p:txBody>
-          <a:bodyPr wrap="square" lIns="0" tIns="0" rIns="0" bIns="0" rtlCol="0" anchor="ctr"/>
+          <a:bodyPr wrap="square" lIns="0" tIns="0" rIns="0" bIns="0" rtlCol="0" anchor="t"/>
           <a:lstStyle/>
           <a:p>
             <a:pPr indent="0" marL="0">
@@ -15008,7 +15008,7 @@
           <a:ln/>
         </p:spPr>
         <p:txBody>
-          <a:bodyPr wrap="square" lIns="0" tIns="0" rIns="0" bIns="0" rtlCol="0" anchor="ctr"/>
+          <a:bodyPr wrap="square" lIns="0" tIns="0" rIns="0" bIns="0" rtlCol="0" anchor="t"/>
           <a:lstStyle/>
           <a:p>
             <a:pPr indent="0" marL="0">
@@ -15047,7 +15047,7 @@
           <a:ln/>
         </p:spPr>
         <p:txBody>
-          <a:bodyPr wrap="square" lIns="0" tIns="0" rIns="0" bIns="0" rtlCol="0" anchor="ctr"/>
+          <a:bodyPr wrap="square" lIns="0" tIns="0" rIns="0" bIns="0" rtlCol="0" anchor="t"/>
           <a:lstStyle/>
           <a:p>
             <a:pPr indent="0" marL="0">
@@ -15086,7 +15086,7 @@
           <a:ln/>
         </p:spPr>
         <p:txBody>
-          <a:bodyPr wrap="square" lIns="0" tIns="0" rIns="0" bIns="0" rtlCol="0" anchor="ctr"/>
+          <a:bodyPr wrap="square" lIns="0" tIns="0" rIns="0" bIns="0" rtlCol="0" anchor="t"/>
           <a:lstStyle/>
           <a:p>
             <a:pPr indent="0" marL="0">
@@ -15157,7 +15157,7 @@
           <a:ln/>
         </p:spPr>
         <p:txBody>
-          <a:bodyPr wrap="square" lIns="0" tIns="0" rIns="0" bIns="0" rtlCol="0" anchor="ctr"/>
+          <a:bodyPr wrap="square" lIns="0" tIns="0" rIns="0" bIns="0" rtlCol="0" anchor="t"/>
           <a:lstStyle/>
           <a:p>
             <a:pPr indent="0" marL="0">
@@ -15235,7 +15235,7 @@
           <a:ln/>
         </p:spPr>
         <p:txBody>
-          <a:bodyPr wrap="square" lIns="0" tIns="0" rIns="0" bIns="0" rtlCol="0" anchor="ctr"/>
+          <a:bodyPr wrap="square" lIns="0" tIns="0" rIns="0" bIns="0" rtlCol="0" anchor="t"/>
           <a:lstStyle/>
           <a:p>
             <a:pPr indent="0" marL="0">
@@ -15274,7 +15274,7 @@
           <a:ln/>
         </p:spPr>
         <p:txBody>
-          <a:bodyPr wrap="square" lIns="0" tIns="0" rIns="0" bIns="0" rtlCol="0" anchor="ctr"/>
+          <a:bodyPr wrap="square" lIns="0" tIns="0" rIns="0" bIns="0" rtlCol="0" anchor="t"/>
           <a:lstStyle/>
           <a:p>
             <a:pPr algn="r" indent="0" marL="0">
@@ -15362,7 +15362,7 @@
           <a:ln/>
         </p:spPr>
         <p:txBody>
-          <a:bodyPr wrap="square" lIns="0" tIns="0" rIns="0" bIns="0" rtlCol="0" anchor="ctr"/>
+          <a:bodyPr wrap="square" lIns="0" tIns="0" rIns="0" bIns="0" rtlCol="0" anchor="t"/>
           <a:lstStyle/>
           <a:p>
             <a:pPr indent="0" marL="0">
@@ -15489,7 +15489,7 @@
           <a:ln/>
         </p:spPr>
         <p:txBody>
-          <a:bodyPr wrap="square" lIns="0" tIns="0" rIns="0" bIns="0" rtlCol="0" anchor="ctr"/>
+          <a:bodyPr wrap="square" lIns="0" tIns="0" rIns="0" bIns="0" rtlCol="0" anchor="t"/>
           <a:lstStyle/>
           <a:p>
             <a:pPr indent="0" marL="0">
@@ -15616,7 +15616,7 @@
           <a:ln/>
         </p:spPr>
         <p:txBody>
-          <a:bodyPr wrap="square" lIns="0" tIns="0" rIns="0" bIns="0" rtlCol="0" anchor="ctr"/>
+          <a:bodyPr wrap="square" lIns="0" tIns="0" rIns="0" bIns="0" rtlCol="0" anchor="t"/>
           <a:lstStyle/>
           <a:p>
             <a:pPr indent="0" marL="0">
@@ -15743,7 +15743,7 @@
           <a:ln/>
         </p:spPr>
         <p:txBody>
-          <a:bodyPr wrap="square" lIns="0" tIns="0" rIns="0" bIns="0" rtlCol="0" anchor="ctr"/>
+          <a:bodyPr wrap="square" lIns="0" tIns="0" rIns="0" bIns="0" rtlCol="0" anchor="t"/>
           <a:lstStyle/>
           <a:p>
             <a:pPr indent="0" marL="0">
@@ -15853,7 +15853,7 @@
           <a:ln/>
         </p:spPr>
         <p:txBody>
-          <a:bodyPr wrap="square" lIns="0" tIns="0" rIns="0" bIns="0" rtlCol="0" anchor="ctr"/>
+          <a:bodyPr wrap="square" lIns="0" tIns="0" rIns="0" bIns="0" rtlCol="0" anchor="t"/>
           <a:lstStyle/>
           <a:p>
             <a:pPr algn="r" indent="0" marL="0">
@@ -15892,7 +15892,7 @@
           <a:ln/>
         </p:spPr>
         <p:txBody>
-          <a:bodyPr wrap="square" lIns="0" tIns="0" rIns="0" bIns="0" rtlCol="0" anchor="ctr"/>
+          <a:bodyPr wrap="square" lIns="0" tIns="0" rIns="0" bIns="0" rtlCol="0" anchor="t"/>
           <a:lstStyle/>
           <a:p>
             <a:pPr indent="0" marL="0">
@@ -15931,7 +15931,7 @@
           <a:ln/>
         </p:spPr>
         <p:txBody>
-          <a:bodyPr wrap="square" lIns="0" tIns="0" rIns="0" bIns="0" rtlCol="0" anchor="ctr"/>
+          <a:bodyPr wrap="square" lIns="0" tIns="0" rIns="0" bIns="0" rtlCol="0" anchor="t"/>
           <a:lstStyle/>
           <a:p>
             <a:pPr indent="0" marL="0">
@@ -16085,7 +16085,7 @@
           <a:ln/>
         </p:spPr>
         <p:txBody>
-          <a:bodyPr wrap="square" lIns="0" tIns="0" rIns="0" bIns="0" rtlCol="0" anchor="ctr"/>
+          <a:bodyPr wrap="square" lIns="0" tIns="0" rIns="0" bIns="0" rtlCol="0" anchor="t"/>
           <a:lstStyle/>
           <a:p>
             <a:pPr indent="0" marL="0">
@@ -16124,7 +16124,7 @@
           <a:ln/>
         </p:spPr>
         <p:txBody>
-          <a:bodyPr wrap="square" lIns="0" tIns="0" rIns="0" bIns="0" rtlCol="0" anchor="ctr"/>
+          <a:bodyPr wrap="square" lIns="0" tIns="0" rIns="0" bIns="0" rtlCol="0" anchor="t"/>
           <a:lstStyle/>
           <a:p>
             <a:pPr indent="0" marL="0">
@@ -16239,7 +16239,7 @@
           <a:ln/>
         </p:spPr>
         <p:txBody>
-          <a:bodyPr wrap="square" lIns="0" tIns="0" rIns="0" bIns="0" rtlCol="0" anchor="ctr"/>
+          <a:bodyPr wrap="square" lIns="0" tIns="0" rIns="0" bIns="0" rtlCol="0" anchor="t"/>
           <a:lstStyle/>
           <a:p>
             <a:pPr indent="0" marL="0">
@@ -16278,7 +16278,7 @@
           <a:ln/>
         </p:spPr>
         <p:txBody>
-          <a:bodyPr wrap="square" lIns="0" tIns="0" rIns="0" bIns="0" rtlCol="0" anchor="ctr"/>
+          <a:bodyPr wrap="square" lIns="0" tIns="0" rIns="0" bIns="0" rtlCol="0" anchor="t"/>
           <a:lstStyle/>
           <a:p>
             <a:pPr indent="0" marL="0">
@@ -16393,7 +16393,7 @@
           <a:ln/>
         </p:spPr>
         <p:txBody>
-          <a:bodyPr wrap="square" lIns="0" tIns="0" rIns="0" bIns="0" rtlCol="0" anchor="ctr"/>
+          <a:bodyPr wrap="square" lIns="0" tIns="0" rIns="0" bIns="0" rtlCol="0" anchor="t"/>
           <a:lstStyle/>
           <a:p>
             <a:pPr indent="0" marL="0">
@@ -16432,7 +16432,7 @@
           <a:ln/>
         </p:spPr>
         <p:txBody>
-          <a:bodyPr wrap="square" lIns="0" tIns="0" rIns="0" bIns="0" rtlCol="0" anchor="ctr"/>
+          <a:bodyPr wrap="square" lIns="0" tIns="0" rIns="0" bIns="0" rtlCol="0" anchor="t"/>
           <a:lstStyle/>
           <a:p>
             <a:pPr indent="0" marL="0">
@@ -16547,7 +16547,7 @@
           <a:ln/>
         </p:spPr>
         <p:txBody>
-          <a:bodyPr wrap="square" lIns="0" tIns="0" rIns="0" bIns="0" rtlCol="0" anchor="ctr"/>
+          <a:bodyPr wrap="square" lIns="0" tIns="0" rIns="0" bIns="0" rtlCol="0" anchor="t"/>
           <a:lstStyle/>
           <a:p>
             <a:pPr indent="0" marL="0">
@@ -16586,7 +16586,7 @@
           <a:ln/>
         </p:spPr>
         <p:txBody>
-          <a:bodyPr wrap="square" lIns="0" tIns="0" rIns="0" bIns="0" rtlCol="0" anchor="ctr"/>
+          <a:bodyPr wrap="square" lIns="0" tIns="0" rIns="0" bIns="0" rtlCol="0" anchor="t"/>
           <a:lstStyle/>
           <a:p>
             <a:pPr indent="0" marL="0">
@@ -16657,7 +16657,7 @@
           <a:ln/>
         </p:spPr>
         <p:txBody>
-          <a:bodyPr wrap="square" lIns="0" tIns="0" rIns="0" bIns="0" rtlCol="0" anchor="ctr"/>
+          <a:bodyPr wrap="square" lIns="0" tIns="0" rIns="0" bIns="0" rtlCol="0" anchor="t"/>
           <a:lstStyle/>
           <a:p>
             <a:pPr indent="0" marL="0">
@@ -16735,7 +16735,7 @@
           <a:ln/>
         </p:spPr>
         <p:txBody>
-          <a:bodyPr wrap="square" lIns="0" tIns="0" rIns="0" bIns="0" rtlCol="0" anchor="ctr"/>
+          <a:bodyPr wrap="square" lIns="0" tIns="0" rIns="0" bIns="0" rtlCol="0" anchor="t"/>
           <a:lstStyle/>
           <a:p>
             <a:pPr indent="0" marL="0">
@@ -16774,7 +16774,7 @@
           <a:ln/>
         </p:spPr>
         <p:txBody>
-          <a:bodyPr wrap="square" lIns="0" tIns="0" rIns="0" bIns="0" rtlCol="0" anchor="ctr"/>
+          <a:bodyPr wrap="square" lIns="0" tIns="0" rIns="0" bIns="0" rtlCol="0" anchor="t"/>
           <a:lstStyle/>
           <a:p>
             <a:pPr algn="r" indent="0" marL="0">
@@ -16840,7 +16840,7 @@
           <a:ln/>
         </p:spPr>
         <p:txBody>
-          <a:bodyPr wrap="square" lIns="0" tIns="0" rIns="0" bIns="0" rtlCol="0" anchor="ctr"/>
+          <a:bodyPr wrap="square" lIns="0" tIns="0" rIns="0" bIns="0" rtlCol="0" anchor="t"/>
           <a:lstStyle/>
           <a:p>
             <a:pPr indent="0" marL="0">
@@ -16879,7 +16879,7 @@
           <a:ln/>
         </p:spPr>
         <p:txBody>
-          <a:bodyPr wrap="square" lIns="0" tIns="0" rIns="0" bIns="0" rtlCol="0" anchor="ctr"/>
+          <a:bodyPr wrap="square" lIns="0" tIns="0" rIns="0" bIns="0" rtlCol="0" anchor="t"/>
           <a:lstStyle/>
           <a:p>
             <a:pPr indent="0" marL="0">
@@ -16969,7 +16969,7 @@
           <a:ln/>
         </p:spPr>
         <p:txBody>
-          <a:bodyPr wrap="square" lIns="0" tIns="0" rIns="0" bIns="0" rtlCol="0" anchor="ctr"/>
+          <a:bodyPr wrap="square" lIns="0" tIns="0" rIns="0" bIns="0" rtlCol="0" anchor="t"/>
           <a:lstStyle/>
           <a:p>
             <a:pPr indent="0" marL="0">
@@ -17008,7 +17008,7 @@
           <a:ln/>
         </p:spPr>
         <p:txBody>
-          <a:bodyPr wrap="square" lIns="0" tIns="0" rIns="0" bIns="0" rtlCol="0" anchor="ctr"/>
+          <a:bodyPr wrap="square" lIns="0" tIns="0" rIns="0" bIns="0" rtlCol="0" anchor="t"/>
           <a:lstStyle/>
           <a:p>
             <a:pPr indent="0" marL="0">
@@ -17098,7 +17098,7 @@
           <a:ln/>
         </p:spPr>
         <p:txBody>
-          <a:bodyPr wrap="square" lIns="0" tIns="0" rIns="0" bIns="0" rtlCol="0" anchor="ctr"/>
+          <a:bodyPr wrap="square" lIns="0" tIns="0" rIns="0" bIns="0" rtlCol="0" anchor="t"/>
           <a:lstStyle/>
           <a:p>
             <a:pPr indent="0" marL="0">
@@ -17137,7 +17137,7 @@
           <a:ln/>
         </p:spPr>
         <p:txBody>
-          <a:bodyPr wrap="square" lIns="0" tIns="0" rIns="0" bIns="0" rtlCol="0" anchor="ctr"/>
+          <a:bodyPr wrap="square" lIns="0" tIns="0" rIns="0" bIns="0" rtlCol="0" anchor="t"/>
           <a:lstStyle/>
           <a:p>
             <a:pPr indent="0" marL="0">
@@ -17227,7 +17227,7 @@
           <a:ln/>
         </p:spPr>
         <p:txBody>
-          <a:bodyPr wrap="square" lIns="0" tIns="0" rIns="0" bIns="0" rtlCol="0" anchor="ctr"/>
+          <a:bodyPr wrap="square" lIns="0" tIns="0" rIns="0" bIns="0" rtlCol="0" anchor="t"/>
           <a:lstStyle/>
           <a:p>
             <a:pPr indent="0" marL="0">
@@ -17266,7 +17266,7 @@
           <a:ln/>
         </p:spPr>
         <p:txBody>
-          <a:bodyPr wrap="square" lIns="0" tIns="0" rIns="0" bIns="0" rtlCol="0" anchor="ctr"/>
+          <a:bodyPr wrap="square" lIns="0" tIns="0" rIns="0" bIns="0" rtlCol="0" anchor="t"/>
           <a:lstStyle/>
           <a:p>
             <a:pPr indent="0" marL="0">
@@ -17356,7 +17356,7 @@
           <a:ln/>
         </p:spPr>
         <p:txBody>
-          <a:bodyPr wrap="square" lIns="0" tIns="0" rIns="0" bIns="0" rtlCol="0" anchor="ctr"/>
+          <a:bodyPr wrap="square" lIns="0" tIns="0" rIns="0" bIns="0" rtlCol="0" anchor="t"/>
           <a:lstStyle/>
           <a:p>
             <a:pPr algn="ctr" indent="0" marL="0">
@@ -17395,7 +17395,7 @@
           <a:ln/>
         </p:spPr>
         <p:txBody>
-          <a:bodyPr wrap="square" lIns="0" tIns="0" rIns="0" bIns="0" rtlCol="0" anchor="ctr"/>
+          <a:bodyPr wrap="square" lIns="0" tIns="0" rIns="0" bIns="0" rtlCol="0" anchor="t"/>
           <a:lstStyle/>
           <a:p>
             <a:pPr algn="ctr" indent="0" marL="0">
@@ -17485,7 +17485,7 @@
           <a:ln/>
         </p:spPr>
         <p:txBody>
-          <a:bodyPr wrap="square" lIns="0" tIns="0" rIns="0" bIns="0" rtlCol="0" anchor="ctr"/>
+          <a:bodyPr wrap="square" lIns="0" tIns="0" rIns="0" bIns="0" rtlCol="0" anchor="t"/>
           <a:lstStyle/>
           <a:p>
             <a:pPr algn="ctr" indent="0" marL="0">
@@ -17563,7 +17563,7 @@
           <a:ln/>
         </p:spPr>
         <p:txBody>
-          <a:bodyPr wrap="square" lIns="0" tIns="0" rIns="0" bIns="0" rtlCol="0" anchor="ctr"/>
+          <a:bodyPr wrap="square" lIns="0" tIns="0" rIns="0" bIns="0" rtlCol="0" anchor="t"/>
           <a:lstStyle/>
           <a:p>
             <a:pPr indent="0" marL="0">
@@ -17634,7 +17634,7 @@
           <a:ln/>
         </p:spPr>
         <p:txBody>
-          <a:bodyPr wrap="square" lIns="0" tIns="0" rIns="0" bIns="0" rtlCol="0" anchor="ctr"/>
+          <a:bodyPr wrap="square" lIns="0" tIns="0" rIns="0" bIns="0" rtlCol="0" anchor="t"/>
           <a:lstStyle/>
           <a:p>
             <a:pPr indent="0" marL="0">
@@ -17712,7 +17712,7 @@
           <a:ln/>
         </p:spPr>
         <p:txBody>
-          <a:bodyPr wrap="square" lIns="0" tIns="0" rIns="0" bIns="0" rtlCol="0" anchor="ctr"/>
+          <a:bodyPr wrap="square" lIns="0" tIns="0" rIns="0" bIns="0" rtlCol="0" anchor="t"/>
           <a:lstStyle/>
           <a:p>
             <a:pPr indent="0" marL="0">
@@ -17751,7 +17751,7 @@
           <a:ln/>
         </p:spPr>
         <p:txBody>
-          <a:bodyPr wrap="square" lIns="0" tIns="0" rIns="0" bIns="0" rtlCol="0" anchor="ctr"/>
+          <a:bodyPr wrap="square" lIns="0" tIns="0" rIns="0" bIns="0" rtlCol="0" anchor="t"/>
           <a:lstStyle/>
           <a:p>
             <a:pPr algn="r" indent="0" marL="0">
@@ -17817,7 +17817,7 @@
           <a:ln/>
         </p:spPr>
         <p:txBody>
-          <a:bodyPr wrap="square" lIns="0" tIns="0" rIns="0" bIns="0" rtlCol="0" anchor="ctr"/>
+          <a:bodyPr wrap="square" lIns="0" tIns="0" rIns="0" bIns="0" rtlCol="0" anchor="t"/>
           <a:lstStyle/>
           <a:p>
             <a:pPr indent="0" marL="0">
@@ -17989,7 +17989,7 @@
           <a:ln/>
         </p:spPr>
         <p:txBody>
-          <a:bodyPr wrap="square" lIns="0" tIns="0" rIns="0" bIns="0" rtlCol="0" anchor="ctr"/>
+          <a:bodyPr wrap="square" lIns="0" tIns="0" rIns="0" bIns="0" rtlCol="0" anchor="t"/>
           <a:lstStyle/>
           <a:p>
             <a:pPr indent="0" marL="0">
@@ -18094,7 +18094,7 @@
           <a:ln/>
         </p:spPr>
         <p:txBody>
-          <a:bodyPr wrap="square" lIns="0" tIns="0" rIns="0" bIns="0" rtlCol="0" anchor="ctr"/>
+          <a:bodyPr wrap="square" lIns="0" tIns="0" rIns="0" bIns="0" rtlCol="0" anchor="t"/>
           <a:lstStyle/>
           <a:p>
             <a:pPr indent="0" marL="0">
@@ -18204,7 +18204,7 @@
           <a:ln/>
         </p:spPr>
         <p:txBody>
-          <a:bodyPr wrap="square" lIns="0" tIns="0" rIns="0" bIns="0" rtlCol="0" anchor="ctr"/>
+          <a:bodyPr wrap="square" lIns="0" tIns="0" rIns="0" bIns="0" rtlCol="0" anchor="t"/>
           <a:lstStyle/>
           <a:p>
             <a:pPr indent="0" marL="0">
@@ -18282,7 +18282,7 @@
           <a:ln/>
         </p:spPr>
         <p:txBody>
-          <a:bodyPr wrap="square" lIns="0" tIns="0" rIns="0" bIns="0" rtlCol="0" anchor="ctr"/>
+          <a:bodyPr wrap="square" lIns="0" tIns="0" rIns="0" bIns="0" rtlCol="0" anchor="t"/>
           <a:lstStyle/>
           <a:p>
             <a:pPr indent="0" marL="0">
@@ -18321,7 +18321,7 @@
           <a:ln/>
         </p:spPr>
         <p:txBody>
-          <a:bodyPr wrap="square" lIns="0" tIns="0" rIns="0" bIns="0" rtlCol="0" anchor="ctr"/>
+          <a:bodyPr wrap="square" lIns="0" tIns="0" rIns="0" bIns="0" rtlCol="0" anchor="t"/>
           <a:lstStyle/>
           <a:p>
             <a:pPr algn="r" indent="0" marL="0">
@@ -18370,7 +18370,7 @@
                 <a:gridCol w="1828800"/>
                 <a:gridCol w="731520"/>
               </a:tblGrid>
-              <a:tr h="384048">
+              <a:tr h="420624">
                 <a:tc>
                   <a:txBody>
                     <a:bodyPr/>
@@ -18397,7 +18397,7 @@
                       </a:endParaRPr>
                     </a:p>
                   </a:txBody>
-                  <a:tcPr marL="91440" marR="91440" marT="45720" marB="45720">
+                  <a:tcPr marL="91440" marR="91440" marT="45720" marB="45720" anchor="ctr">
                     <a:lnL w="6350" cap="flat" cmpd="sng" algn="ctr">
                       <a:solidFill>
                         <a:srgbClr val="E6DDE0"/>
@@ -18465,7 +18465,7 @@
                       </a:endParaRPr>
                     </a:p>
                   </a:txBody>
-                  <a:tcPr marL="91440" marR="91440" marT="45720" marB="45720">
+                  <a:tcPr marL="91440" marR="91440" marT="45720" marB="45720" anchor="ctr">
                     <a:lnL w="6350" cap="flat" cmpd="sng" algn="ctr">
                       <a:solidFill>
                         <a:srgbClr val="E6DDE0"/>
@@ -18533,7 +18533,7 @@
                       </a:endParaRPr>
                     </a:p>
                   </a:txBody>
-                  <a:tcPr marL="91440" marR="91440" marT="45720" marB="45720">
+                  <a:tcPr marL="91440" marR="91440" marT="45720" marB="45720" anchor="ctr">
                     <a:lnL w="6350" cap="flat" cmpd="sng" algn="ctr">
                       <a:solidFill>
                         <a:srgbClr val="E6DDE0"/>
@@ -18601,7 +18601,7 @@
                       </a:endParaRPr>
                     </a:p>
                   </a:txBody>
-                  <a:tcPr marL="91440" marR="91440" marT="45720" marB="45720">
+                  <a:tcPr marL="91440" marR="91440" marT="45720" marB="45720" anchor="ctr">
                     <a:lnL w="6350" cap="flat" cmpd="sng" algn="ctr">
                       <a:solidFill>
                         <a:srgbClr val="E6DDE0"/>
@@ -18644,7 +18644,7 @@
                   </a:tcPr>
                 </a:tc>
               </a:tr>
-              <a:tr h="384048">
+              <a:tr h="420624">
                 <a:tc>
                   <a:txBody>
                     <a:bodyPr/>
@@ -18671,7 +18671,7 @@
                       </a:endParaRPr>
                     </a:p>
                   </a:txBody>
-                  <a:tcPr marL="91440" marR="91440" marT="45720" marB="45720">
+                  <a:tcPr marL="91440" marR="91440" marT="45720" marB="45720" anchor="ctr">
                     <a:lnL w="6350" cap="flat" cmpd="sng" algn="ctr">
                       <a:solidFill>
                         <a:srgbClr val="E6DDE0"/>
@@ -18739,7 +18739,7 @@
                       </a:endParaRPr>
                     </a:p>
                   </a:txBody>
-                  <a:tcPr marL="91440" marR="91440" marT="45720" marB="45720">
+                  <a:tcPr marL="91440" marR="91440" marT="45720" marB="45720" anchor="ctr">
                     <a:lnL w="6350" cap="flat" cmpd="sng" algn="ctr">
                       <a:solidFill>
                         <a:srgbClr val="E6DDE0"/>
@@ -18807,7 +18807,7 @@
                       </a:endParaRPr>
                     </a:p>
                   </a:txBody>
-                  <a:tcPr marL="91440" marR="91440" marT="45720" marB="45720">
+                  <a:tcPr marL="91440" marR="91440" marT="45720" marB="45720" anchor="ctr">
                     <a:lnL w="6350" cap="flat" cmpd="sng" algn="ctr">
                       <a:solidFill>
                         <a:srgbClr val="E6DDE0"/>
@@ -18875,7 +18875,7 @@
                       </a:endParaRPr>
                     </a:p>
                   </a:txBody>
-                  <a:tcPr marL="91440" marR="91440" marT="45720" marB="45720">
+                  <a:tcPr marL="91440" marR="91440" marT="45720" marB="45720" anchor="ctr">
                     <a:lnL w="6350" cap="flat" cmpd="sng" algn="ctr">
                       <a:solidFill>
                         <a:srgbClr val="E6DDE0"/>
@@ -18918,7 +18918,7 @@
                   </a:tcPr>
                 </a:tc>
               </a:tr>
-              <a:tr h="384048">
+              <a:tr h="420624">
                 <a:tc>
                   <a:txBody>
                     <a:bodyPr/>
@@ -18945,7 +18945,7 @@
                       </a:endParaRPr>
                     </a:p>
                   </a:txBody>
-                  <a:tcPr marL="91440" marR="91440" marT="45720" marB="45720">
+                  <a:tcPr marL="91440" marR="91440" marT="45720" marB="45720" anchor="ctr">
                     <a:lnL w="6350" cap="flat" cmpd="sng" algn="ctr">
                       <a:solidFill>
                         <a:srgbClr val="E6DDE0"/>
@@ -19013,7 +19013,7 @@
                       </a:endParaRPr>
                     </a:p>
                   </a:txBody>
-                  <a:tcPr marL="91440" marR="91440" marT="45720" marB="45720">
+                  <a:tcPr marL="91440" marR="91440" marT="45720" marB="45720" anchor="ctr">
                     <a:lnL w="6350" cap="flat" cmpd="sng" algn="ctr">
                       <a:solidFill>
                         <a:srgbClr val="E6DDE0"/>
@@ -19081,7 +19081,7 @@
                       </a:endParaRPr>
                     </a:p>
                   </a:txBody>
-                  <a:tcPr marL="91440" marR="91440" marT="45720" marB="45720">
+                  <a:tcPr marL="91440" marR="91440" marT="45720" marB="45720" anchor="ctr">
                     <a:lnL w="6350" cap="flat" cmpd="sng" algn="ctr">
                       <a:solidFill>
                         <a:srgbClr val="E6DDE0"/>
@@ -19149,7 +19149,7 @@
                       </a:endParaRPr>
                     </a:p>
                   </a:txBody>
-                  <a:tcPr marL="91440" marR="91440" marT="45720" marB="45720">
+                  <a:tcPr marL="91440" marR="91440" marT="45720" marB="45720" anchor="ctr">
                     <a:lnL w="6350" cap="flat" cmpd="sng" algn="ctr">
                       <a:solidFill>
                         <a:srgbClr val="E6DDE0"/>
@@ -19192,7 +19192,7 @@
                   </a:tcPr>
                 </a:tc>
               </a:tr>
-              <a:tr h="384048">
+              <a:tr h="420624">
                 <a:tc>
                   <a:txBody>
                     <a:bodyPr/>
@@ -19219,7 +19219,7 @@
                       </a:endParaRPr>
                     </a:p>
                   </a:txBody>
-                  <a:tcPr marL="91440" marR="91440" marT="45720" marB="45720">
+                  <a:tcPr marL="91440" marR="91440" marT="45720" marB="45720" anchor="ctr">
                     <a:lnL w="6350" cap="flat" cmpd="sng" algn="ctr">
                       <a:solidFill>
                         <a:srgbClr val="E6DDE0"/>
@@ -19287,7 +19287,7 @@
                       </a:endParaRPr>
                     </a:p>
                   </a:txBody>
-                  <a:tcPr marL="91440" marR="91440" marT="45720" marB="45720">
+                  <a:tcPr marL="91440" marR="91440" marT="45720" marB="45720" anchor="ctr">
                     <a:lnL w="6350" cap="flat" cmpd="sng" algn="ctr">
                       <a:solidFill>
                         <a:srgbClr val="E6DDE0"/>
@@ -19355,7 +19355,7 @@
                       </a:endParaRPr>
                     </a:p>
                   </a:txBody>
-                  <a:tcPr marL="91440" marR="91440" marT="45720" marB="45720">
+                  <a:tcPr marL="91440" marR="91440" marT="45720" marB="45720" anchor="ctr">
                     <a:lnL w="6350" cap="flat" cmpd="sng" algn="ctr">
                       <a:solidFill>
                         <a:srgbClr val="E6DDE0"/>
@@ -19423,7 +19423,7 @@
                       </a:endParaRPr>
                     </a:p>
                   </a:txBody>
-                  <a:tcPr marL="91440" marR="91440" marT="45720" marB="45720">
+                  <a:tcPr marL="91440" marR="91440" marT="45720" marB="45720" anchor="ctr">
                     <a:lnL w="6350" cap="flat" cmpd="sng" algn="ctr">
                       <a:solidFill>
                         <a:srgbClr val="E6DDE0"/>
@@ -19466,7 +19466,7 @@
                   </a:tcPr>
                 </a:tc>
               </a:tr>
-              <a:tr h="384048">
+              <a:tr h="420624">
                 <a:tc>
                   <a:txBody>
                     <a:bodyPr/>
@@ -19493,7 +19493,7 @@
                       </a:endParaRPr>
                     </a:p>
                   </a:txBody>
-                  <a:tcPr marL="91440" marR="91440" marT="45720" marB="45720">
+                  <a:tcPr marL="91440" marR="91440" marT="45720" marB="45720" anchor="ctr">
                     <a:lnL w="6350" cap="flat" cmpd="sng" algn="ctr">
                       <a:solidFill>
                         <a:srgbClr val="E6DDE0"/>
@@ -19561,7 +19561,7 @@
                       </a:endParaRPr>
                     </a:p>
                   </a:txBody>
-                  <a:tcPr marL="91440" marR="91440" marT="45720" marB="45720">
+                  <a:tcPr marL="91440" marR="91440" marT="45720" marB="45720" anchor="ctr">
                     <a:lnL w="6350" cap="flat" cmpd="sng" algn="ctr">
                       <a:solidFill>
                         <a:srgbClr val="E6DDE0"/>
@@ -19629,7 +19629,7 @@
                       </a:endParaRPr>
                     </a:p>
                   </a:txBody>
-                  <a:tcPr marL="91440" marR="91440" marT="45720" marB="45720">
+                  <a:tcPr marL="91440" marR="91440" marT="45720" marB="45720" anchor="ctr">
                     <a:lnL w="6350" cap="flat" cmpd="sng" algn="ctr">
                       <a:solidFill>
                         <a:srgbClr val="E6DDE0"/>
@@ -19697,7 +19697,7 @@
                       </a:endParaRPr>
                     </a:p>
                   </a:txBody>
-                  <a:tcPr marL="91440" marR="91440" marT="45720" marB="45720">
+                  <a:tcPr marL="91440" marR="91440" marT="45720" marB="45720" anchor="ctr">
                     <a:lnL w="6350" cap="flat" cmpd="sng" algn="ctr">
                       <a:solidFill>
                         <a:srgbClr val="E6DDE0"/>
@@ -19789,7 +19789,7 @@
           <a:ln/>
         </p:spPr>
         <p:txBody>
-          <a:bodyPr wrap="square" lIns="0" tIns="0" rIns="0" bIns="0" rtlCol="0" anchor="ctr"/>
+          <a:bodyPr wrap="square" lIns="0" tIns="0" rIns="0" bIns="0" rtlCol="0" anchor="t"/>
           <a:lstStyle/>
           <a:p>
             <a:pPr indent="0" marL="0">
@@ -19955,7 +19955,7 @@
           <a:ln/>
         </p:spPr>
         <p:txBody>
-          <a:bodyPr wrap="square" lIns="0" tIns="0" rIns="0" bIns="0" rtlCol="0" anchor="ctr"/>
+          <a:bodyPr wrap="square" lIns="0" tIns="0" rIns="0" bIns="0" rtlCol="0" anchor="t"/>
           <a:lstStyle/>
           <a:p>
             <a:pPr indent="0" marL="0">
@@ -20026,7 +20026,7 @@
           <a:ln/>
         </p:spPr>
         <p:txBody>
-          <a:bodyPr wrap="square" lIns="0" tIns="0" rIns="0" bIns="0" rtlCol="0" anchor="ctr"/>
+          <a:bodyPr wrap="square" lIns="0" tIns="0" rIns="0" bIns="0" rtlCol="0" anchor="t"/>
           <a:lstStyle/>
           <a:p>
             <a:pPr indent="0" marL="0">
@@ -20104,7 +20104,7 @@
           <a:ln/>
         </p:spPr>
         <p:txBody>
-          <a:bodyPr wrap="square" lIns="0" tIns="0" rIns="0" bIns="0" rtlCol="0" anchor="ctr"/>
+          <a:bodyPr wrap="square" lIns="0" tIns="0" rIns="0" bIns="0" rtlCol="0" anchor="t"/>
           <a:lstStyle/>
           <a:p>
             <a:pPr indent="0" marL="0">
@@ -20143,7 +20143,7 @@
           <a:ln/>
         </p:spPr>
         <p:txBody>
-          <a:bodyPr wrap="square" lIns="0" tIns="0" rIns="0" bIns="0" rtlCol="0" anchor="ctr"/>
+          <a:bodyPr wrap="square" lIns="0" tIns="0" rIns="0" bIns="0" rtlCol="0" anchor="t"/>
           <a:lstStyle/>
           <a:p>
             <a:pPr algn="r" indent="0" marL="0">
@@ -20182,7 +20182,7 @@
           <a:ln/>
         </p:spPr>
         <p:txBody>
-          <a:bodyPr wrap="square" lIns="0" tIns="0" rIns="0" bIns="0" rtlCol="0" anchor="ctr"/>
+          <a:bodyPr wrap="square" lIns="0" tIns="0" rIns="0" bIns="0" rtlCol="0" anchor="t"/>
           <a:lstStyle/>
           <a:p>
             <a:pPr algn="ctr" indent="0" marL="0">
@@ -20221,7 +20221,7 @@
           <a:ln/>
         </p:spPr>
         <p:txBody>
-          <a:bodyPr wrap="square" lIns="0" tIns="0" rIns="0" bIns="0" rtlCol="0" anchor="ctr"/>
+          <a:bodyPr wrap="square" lIns="0" tIns="0" rIns="0" bIns="0" rtlCol="0" anchor="t"/>
           <a:lstStyle/>
           <a:p>
             <a:pPr algn="ctr" indent="0" marL="0">
@@ -20260,7 +20260,7 @@
           <a:ln/>
         </p:spPr>
         <p:txBody>
-          <a:bodyPr wrap="square" lIns="0" tIns="0" rIns="0" bIns="0" rtlCol="0" anchor="ctr"/>
+          <a:bodyPr wrap="square" lIns="0" tIns="0" rIns="0" bIns="0" rtlCol="0" anchor="t"/>
           <a:lstStyle/>
           <a:p>
             <a:pPr algn="ctr" indent="0" marL="0">
@@ -20299,7 +20299,7 @@
           <a:ln/>
         </p:spPr>
         <p:txBody>
-          <a:bodyPr wrap="square" lIns="0" tIns="0" rIns="0" bIns="0" rtlCol="0" anchor="ctr"/>
+          <a:bodyPr wrap="square" lIns="0" tIns="0" rIns="0" bIns="0" rtlCol="0" anchor="t"/>
           <a:lstStyle/>
           <a:p>
             <a:pPr algn="ctr" indent="0" marL="0">
@@ -20338,7 +20338,7 @@
           <a:ln/>
         </p:spPr>
         <p:txBody>
-          <a:bodyPr wrap="square" lIns="0" tIns="0" rIns="0" bIns="0" rtlCol="0" anchor="ctr"/>
+          <a:bodyPr wrap="square" lIns="0" tIns="0" rIns="0" bIns="0" rtlCol="0" anchor="t"/>
           <a:lstStyle/>
           <a:p>
             <a:pPr algn="ctr" indent="0" marL="0">
@@ -20377,7 +20377,7 @@
           <a:ln/>
         </p:spPr>
         <p:txBody>
-          <a:bodyPr wrap="square" lIns="0" tIns="0" rIns="0" bIns="0" rtlCol="0" anchor="ctr"/>
+          <a:bodyPr wrap="square" lIns="0" tIns="0" rIns="0" bIns="0" rtlCol="0" anchor="t"/>
           <a:lstStyle/>
           <a:p>
             <a:pPr algn="ctr" indent="0" marL="0">
@@ -20416,7 +20416,7 @@
           <a:ln/>
         </p:spPr>
         <p:txBody>
-          <a:bodyPr wrap="square" lIns="0" tIns="0" rIns="0" bIns="0" rtlCol="0" anchor="ctr"/>
+          <a:bodyPr wrap="square" lIns="0" tIns="0" rIns="0" bIns="0" rtlCol="0" anchor="t"/>
           <a:lstStyle/>
           <a:p>
             <a:pPr algn="ctr" indent="0" marL="0">
@@ -20455,7 +20455,7 @@
           <a:ln/>
         </p:spPr>
         <p:txBody>
-          <a:bodyPr wrap="square" lIns="0" tIns="0" rIns="0" bIns="0" rtlCol="0" anchor="ctr"/>
+          <a:bodyPr wrap="square" lIns="0" tIns="0" rIns="0" bIns="0" rtlCol="0" anchor="t"/>
           <a:lstStyle/>
           <a:p>
             <a:pPr algn="ctr" indent="0" marL="0">
@@ -21163,7 +21163,7 @@
           <a:ln/>
         </p:spPr>
         <p:txBody>
-          <a:bodyPr wrap="square" lIns="0" tIns="0" rIns="0" bIns="0" rtlCol="0" anchor="ctr"/>
+          <a:bodyPr wrap="square" lIns="0" tIns="0" rIns="0" bIns="0" rtlCol="0" anchor="t"/>
           <a:lstStyle/>
           <a:p>
             <a:pPr indent="0" marL="0">
@@ -21234,7 +21234,7 @@
           <a:ln/>
         </p:spPr>
         <p:txBody>
-          <a:bodyPr wrap="square" lIns="0" tIns="0" rIns="0" bIns="0" rtlCol="0" anchor="ctr"/>
+          <a:bodyPr wrap="square" lIns="0" tIns="0" rIns="0" bIns="0" rtlCol="0" anchor="t"/>
           <a:lstStyle/>
           <a:p>
             <a:pPr indent="0" marL="0">
@@ -21312,7 +21312,7 @@
           <a:ln/>
         </p:spPr>
         <p:txBody>
-          <a:bodyPr wrap="square" lIns="0" tIns="0" rIns="0" bIns="0" rtlCol="0" anchor="ctr"/>
+          <a:bodyPr wrap="square" lIns="0" tIns="0" rIns="0" bIns="0" rtlCol="0" anchor="t"/>
           <a:lstStyle/>
           <a:p>
             <a:pPr indent="0" marL="0">
@@ -21351,7 +21351,7 @@
           <a:ln/>
         </p:spPr>
         <p:txBody>
-          <a:bodyPr wrap="square" lIns="0" tIns="0" rIns="0" bIns="0" rtlCol="0" anchor="ctr"/>
+          <a:bodyPr wrap="square" lIns="0" tIns="0" rIns="0" bIns="0" rtlCol="0" anchor="t"/>
           <a:lstStyle/>
           <a:p>
             <a:pPr algn="r" indent="0" marL="0">
@@ -21466,7 +21466,7 @@
           <a:ln/>
         </p:spPr>
         <p:txBody>
-          <a:bodyPr wrap="square" lIns="0" tIns="0" rIns="0" bIns="0" rtlCol="0" anchor="ctr"/>
+          <a:bodyPr wrap="square" lIns="0" tIns="0" rIns="0" bIns="0" rtlCol="0" anchor="t"/>
           <a:lstStyle/>
           <a:p>
             <a:pPr indent="0" marL="0">
@@ -21666,7 +21666,7 @@
           <a:ln/>
         </p:spPr>
         <p:txBody>
-          <a:bodyPr wrap="square" lIns="0" tIns="0" rIns="0" bIns="0" rtlCol="0" anchor="ctr"/>
+          <a:bodyPr wrap="square" lIns="0" tIns="0" rIns="0" bIns="0" rtlCol="0" anchor="t"/>
           <a:lstStyle/>
           <a:p>
             <a:pPr indent="0" marL="0">
@@ -21866,7 +21866,7 @@
           <a:ln/>
         </p:spPr>
         <p:txBody>
-          <a:bodyPr wrap="square" lIns="0" tIns="0" rIns="0" bIns="0" rtlCol="0" anchor="ctr"/>
+          <a:bodyPr wrap="square" lIns="0" tIns="0" rIns="0" bIns="0" rtlCol="0" anchor="t"/>
           <a:lstStyle/>
           <a:p>
             <a:pPr indent="0" marL="0">
@@ -21990,7 +21990,7 @@
           <a:ln/>
         </p:spPr>
         <p:txBody>
-          <a:bodyPr wrap="square" lIns="0" tIns="0" rIns="0" bIns="0" rtlCol="0" anchor="ctr"/>
+          <a:bodyPr wrap="square" lIns="0" tIns="0" rIns="0" bIns="0" rtlCol="0" anchor="t"/>
           <a:lstStyle/>
           <a:p>
             <a:pPr indent="0" marL="0">

</xml_diff>